<commit_message>
Category- Show data in index page
</commit_message>
<xml_diff>
--- a/.lessons/56 Category, Subcategory and Child Category Setup/3 Category- Working with category create form (part - 2)/1.pptx
+++ b/.lessons/56 Category, Subcategory and Child Category Setup/3 Category- Working with category create form (part - 2)/1.pptx
@@ -7,7 +7,10 @@
   <p:sldIdLst>
     <p:sldId id="413" r:id="rId2"/>
     <p:sldId id="414" r:id="rId3"/>
-    <p:sldId id="400" r:id="rId4"/>
+    <p:sldId id="415" r:id="rId4"/>
+    <p:sldId id="416" r:id="rId5"/>
+    <p:sldId id="417" r:id="rId6"/>
+    <p:sldId id="400" r:id="rId7"/>
   </p:sldIdLst>
   <p:sldSz cx="12192000" cy="6858000"/>
   <p:notesSz cx="6858000" cy="9144000"/>
@@ -261,7 +264,7 @@
           <a:p>
             <a:fld id="{3E102D2E-813C-461C-9963-687A650C48C0}" type="datetimeFigureOut">
               <a:rPr lang="en-US" smtClean="0"/>
-              <a:t>6/26/2025</a:t>
+              <a:t>8/18/2025</a:t>
             </a:fld>
             <a:endParaRPr lang="en-US"/>
           </a:p>
@@ -459,7 +462,7 @@
           <a:p>
             <a:fld id="{3E102D2E-813C-461C-9963-687A650C48C0}" type="datetimeFigureOut">
               <a:rPr lang="en-US" smtClean="0"/>
-              <a:t>6/26/2025</a:t>
+              <a:t>8/18/2025</a:t>
             </a:fld>
             <a:endParaRPr lang="en-US"/>
           </a:p>
@@ -667,7 +670,7 @@
           <a:p>
             <a:fld id="{3E102D2E-813C-461C-9963-687A650C48C0}" type="datetimeFigureOut">
               <a:rPr lang="en-US" smtClean="0"/>
-              <a:t>6/26/2025</a:t>
+              <a:t>8/18/2025</a:t>
             </a:fld>
             <a:endParaRPr lang="en-US"/>
           </a:p>
@@ -865,7 +868,7 @@
           <a:p>
             <a:fld id="{3E102D2E-813C-461C-9963-687A650C48C0}" type="datetimeFigureOut">
               <a:rPr lang="en-US" smtClean="0"/>
-              <a:t>6/26/2025</a:t>
+              <a:t>8/18/2025</a:t>
             </a:fld>
             <a:endParaRPr lang="en-US"/>
           </a:p>
@@ -1140,7 +1143,7 @@
           <a:p>
             <a:fld id="{3E102D2E-813C-461C-9963-687A650C48C0}" type="datetimeFigureOut">
               <a:rPr lang="en-US" smtClean="0"/>
-              <a:t>6/26/2025</a:t>
+              <a:t>8/18/2025</a:t>
             </a:fld>
             <a:endParaRPr lang="en-US"/>
           </a:p>
@@ -1405,7 +1408,7 @@
           <a:p>
             <a:fld id="{3E102D2E-813C-461C-9963-687A650C48C0}" type="datetimeFigureOut">
               <a:rPr lang="en-US" smtClean="0"/>
-              <a:t>6/26/2025</a:t>
+              <a:t>8/18/2025</a:t>
             </a:fld>
             <a:endParaRPr lang="en-US"/>
           </a:p>
@@ -1817,7 +1820,7 @@
           <a:p>
             <a:fld id="{3E102D2E-813C-461C-9963-687A650C48C0}" type="datetimeFigureOut">
               <a:rPr lang="en-US" smtClean="0"/>
-              <a:t>6/26/2025</a:t>
+              <a:t>8/18/2025</a:t>
             </a:fld>
             <a:endParaRPr lang="en-US"/>
           </a:p>
@@ -1958,7 +1961,7 @@
           <a:p>
             <a:fld id="{3E102D2E-813C-461C-9963-687A650C48C0}" type="datetimeFigureOut">
               <a:rPr lang="en-US" smtClean="0"/>
-              <a:t>6/26/2025</a:t>
+              <a:t>8/18/2025</a:t>
             </a:fld>
             <a:endParaRPr lang="en-US"/>
           </a:p>
@@ -2071,7 +2074,7 @@
           <a:p>
             <a:fld id="{3E102D2E-813C-461C-9963-687A650C48C0}" type="datetimeFigureOut">
               <a:rPr lang="en-US" smtClean="0"/>
-              <a:t>6/26/2025</a:t>
+              <a:t>8/18/2025</a:t>
             </a:fld>
             <a:endParaRPr lang="en-US"/>
           </a:p>
@@ -2382,7 +2385,7 @@
           <a:p>
             <a:fld id="{3E102D2E-813C-461C-9963-687A650C48C0}" type="datetimeFigureOut">
               <a:rPr lang="en-US" smtClean="0"/>
-              <a:t>6/26/2025</a:t>
+              <a:t>8/18/2025</a:t>
             </a:fld>
             <a:endParaRPr lang="en-US"/>
           </a:p>
@@ -2670,7 +2673,7 @@
           <a:p>
             <a:fld id="{3E102D2E-813C-461C-9963-687A650C48C0}" type="datetimeFigureOut">
               <a:rPr lang="en-US" smtClean="0"/>
-              <a:t>6/26/2025</a:t>
+              <a:t>8/18/2025</a:t>
             </a:fld>
             <a:endParaRPr lang="en-US"/>
           </a:p>
@@ -2911,7 +2914,7 @@
           <a:p>
             <a:fld id="{3E102D2E-813C-461C-9963-687A650C48C0}" type="datetimeFigureOut">
               <a:rPr lang="en-US" smtClean="0"/>
-              <a:t>6/26/2025</a:t>
+              <a:t>8/18/2025</a:t>
             </a:fld>
             <a:endParaRPr lang="en-US"/>
           </a:p>
@@ -3369,21 +3372,54 @@
               <a:buNone/>
             </a:pPr>
             <a:r>
-              <a:rPr kumimoji="0" lang="en-US" altLang="en-US" sz="1300" b="0" i="0" u="none" strike="noStrike" cap="none" normalizeH="0" baseline="0">
-                <a:ln>
-                  <a:noFill/>
-                </a:ln>
-                <a:solidFill>
-                  <a:schemeClr val="tx1"/>
-                </a:solidFill>
-                <a:effectLst/>
+              <a:rPr lang="en-US" altLang="en-US" sz="1300">
                 <a:latin typeface="Arial" panose="020B0604020202020204" pitchFamily="34" charset="0"/>
               </a:rPr>
-              <a:t>.</a:t>
-            </a:r>
-          </a:p>
-        </p:txBody>
-      </p:sp>
+              <a:t>resources\views\admin\category\create.blade.php</a:t>
+            </a:r>
+            <a:endParaRPr kumimoji="0" lang="en-US" altLang="en-US" sz="1300" b="0" i="0" u="none" strike="noStrike" cap="none" normalizeH="0" baseline="0">
+              <a:ln>
+                <a:noFill/>
+              </a:ln>
+              <a:solidFill>
+                <a:schemeClr val="tx1"/>
+              </a:solidFill>
+              <a:effectLst/>
+              <a:latin typeface="Arial" panose="020B0604020202020204" pitchFamily="34" charset="0"/>
+            </a:endParaRPr>
+          </a:p>
+        </p:txBody>
+      </p:sp>
+      <p:pic>
+        <p:nvPicPr>
+          <p:cNvPr id="4" name="Picture 3">
+            <a:extLst>
+              <a:ext uri="{FF2B5EF4-FFF2-40B4-BE49-F238E27FC236}">
+                <a16:creationId xmlns:a16="http://schemas.microsoft.com/office/drawing/2014/main" id="{4E738A89-7441-DF84-D5D1-4B5A490C690D}"/>
+              </a:ext>
+            </a:extLst>
+          </p:cNvPr>
+          <p:cNvPicPr>
+            <a:picLocks noChangeAspect="1"/>
+          </p:cNvPicPr>
+          <p:nvPr/>
+        </p:nvPicPr>
+        <p:blipFill>
+          <a:blip r:embed="rId2"/>
+          <a:stretch>
+            <a:fillRect/>
+          </a:stretch>
+        </p:blipFill>
+        <p:spPr>
+          <a:xfrm>
+            <a:off x="3011055" y="914514"/>
+            <a:ext cx="9180945" cy="5943486"/>
+          </a:xfrm>
+          <a:prstGeom prst="rect">
+            <a:avLst/>
+          </a:prstGeom>
+        </p:spPr>
+      </p:pic>
     </p:spTree>
     <p:extLst>
       <p:ext uri="{BB962C8B-B14F-4D97-AF65-F5344CB8AC3E}">
@@ -3434,8 +3470,8 @@
         </p:nvSpPr>
         <p:spPr>
           <a:xfrm>
-            <a:off x="217714" y="255046"/>
-            <a:ext cx="11756571" cy="355354"/>
+            <a:off x="73892" y="255046"/>
+            <a:ext cx="7481454" cy="655436"/>
           </a:xfrm>
           <a:prstGeom prst="rect">
             <a:avLst/>
@@ -3455,21 +3491,138 @@
               <a:buNone/>
             </a:pPr>
             <a:r>
-              <a:rPr kumimoji="0" lang="en-US" altLang="en-US" sz="1300" b="0" i="0" u="none" strike="noStrike" cap="none" normalizeH="0" baseline="0">
-                <a:ln>
-                  <a:noFill/>
-                </a:ln>
-                <a:solidFill>
-                  <a:schemeClr val="tx1"/>
-                </a:solidFill>
-                <a:effectLst/>
+              <a:rPr lang="en-US" altLang="en-US" sz="1300">
                 <a:latin typeface="Arial" panose="020B0604020202020204" pitchFamily="34" charset="0"/>
               </a:rPr>
-              <a:t>.</a:t>
-            </a:r>
-          </a:p>
-        </p:txBody>
-      </p:sp>
+              <a:t>Burada </a:t>
+            </a:r>
+            <a:r>
+              <a:rPr lang="en-US" altLang="en-US" sz="1300" b="1">
+                <a:latin typeface="Arial" panose="020B0604020202020204" pitchFamily="34" charset="0"/>
+              </a:rPr>
+              <a:t>'not_in:empty</a:t>
+            </a:r>
+            <a:r>
+              <a:rPr lang="en-US" altLang="en-US" sz="1300">
+                <a:latin typeface="Arial" panose="020B0604020202020204" pitchFamily="34" charset="0"/>
+              </a:rPr>
+              <a:t>’ </a:t>
+            </a:r>
+            <a:r>
+              <a:rPr lang="az-Latn-AZ" altLang="en-US" sz="1300">
+                <a:latin typeface="Arial" panose="020B0604020202020204" pitchFamily="34" charset="0"/>
+              </a:rPr>
+              <a:t>yazmaqda məqsəd odur ki, əgər </a:t>
+            </a:r>
+            <a:r>
+              <a:rPr lang="az-Latn-AZ" altLang="en-US" sz="1300" b="1">
+                <a:latin typeface="Arial" panose="020B0604020202020204" pitchFamily="34" charset="0"/>
+              </a:rPr>
+              <a:t>ikon</a:t>
+            </a:r>
+            <a:r>
+              <a:rPr lang="az-Latn-AZ" altLang="en-US" sz="1300">
+                <a:latin typeface="Arial" panose="020B0604020202020204" pitchFamily="34" charset="0"/>
+              </a:rPr>
+              <a:t> seçilməyibsə həmin </a:t>
+            </a:r>
+            <a:r>
+              <a:rPr lang="az-Latn-AZ" altLang="en-US" sz="1300" b="1">
+                <a:latin typeface="Arial" panose="020B0604020202020204" pitchFamily="34" charset="0"/>
+              </a:rPr>
+              <a:t>icon</a:t>
+            </a:r>
+            <a:r>
+              <a:rPr lang="az-Latn-AZ" altLang="en-US" sz="1300">
+                <a:latin typeface="Arial" panose="020B0604020202020204" pitchFamily="34" charset="0"/>
+              </a:rPr>
+              <a:t> sahəsinin dəyərinin </a:t>
+            </a:r>
+            <a:r>
+              <a:rPr lang="az-Latn-AZ" altLang="en-US" sz="1300" b="1">
+                <a:latin typeface="Arial" panose="020B0604020202020204" pitchFamily="34" charset="0"/>
+              </a:rPr>
+              <a:t>EMPTY</a:t>
+            </a:r>
+            <a:r>
+              <a:rPr lang="az-Latn-AZ" altLang="en-US" sz="1300">
+                <a:latin typeface="Arial" panose="020B0604020202020204" pitchFamily="34" charset="0"/>
+              </a:rPr>
+              <a:t> olmasıdır. Və bizdə deyirik ki, əgər boş deyilsə.</a:t>
+            </a:r>
+            <a:endParaRPr kumimoji="0" lang="en-US" altLang="en-US" sz="1300" b="0" i="0" u="none" strike="noStrike" cap="none" normalizeH="0" baseline="0">
+              <a:ln>
+                <a:noFill/>
+              </a:ln>
+              <a:solidFill>
+                <a:schemeClr val="tx1"/>
+              </a:solidFill>
+              <a:effectLst/>
+              <a:latin typeface="Arial" panose="020B0604020202020204" pitchFamily="34" charset="0"/>
+            </a:endParaRPr>
+          </a:p>
+        </p:txBody>
+      </p:sp>
+      <p:pic>
+        <p:nvPicPr>
+          <p:cNvPr id="4" name="Picture 3">
+            <a:extLst>
+              <a:ext uri="{FF2B5EF4-FFF2-40B4-BE49-F238E27FC236}">
+                <a16:creationId xmlns:a16="http://schemas.microsoft.com/office/drawing/2014/main" id="{BF874F49-27DF-8E4D-9526-ED4E9655CFA5}"/>
+              </a:ext>
+            </a:extLst>
+          </p:cNvPr>
+          <p:cNvPicPr>
+            <a:picLocks noChangeAspect="1"/>
+          </p:cNvPicPr>
+          <p:nvPr/>
+        </p:nvPicPr>
+        <p:blipFill>
+          <a:blip r:embed="rId2"/>
+          <a:stretch>
+            <a:fillRect/>
+          </a:stretch>
+        </p:blipFill>
+        <p:spPr>
+          <a:xfrm>
+            <a:off x="7631430" y="0"/>
+            <a:ext cx="4560570" cy="6858000"/>
+          </a:xfrm>
+          <a:prstGeom prst="rect">
+            <a:avLst/>
+          </a:prstGeom>
+        </p:spPr>
+      </p:pic>
+      <p:pic>
+        <p:nvPicPr>
+          <p:cNvPr id="6" name="Picture 5">
+            <a:extLst>
+              <a:ext uri="{FF2B5EF4-FFF2-40B4-BE49-F238E27FC236}">
+                <a16:creationId xmlns:a16="http://schemas.microsoft.com/office/drawing/2014/main" id="{B86F2ED7-2F50-6814-D197-CDB9517D7D7B}"/>
+              </a:ext>
+            </a:extLst>
+          </p:cNvPr>
+          <p:cNvPicPr>
+            <a:picLocks noChangeAspect="1"/>
+          </p:cNvPicPr>
+          <p:nvPr/>
+        </p:nvPicPr>
+        <p:blipFill>
+          <a:blip r:embed="rId3"/>
+          <a:stretch>
+            <a:fillRect/>
+          </a:stretch>
+        </p:blipFill>
+        <p:spPr>
+          <a:xfrm>
+            <a:off x="0" y="1330574"/>
+            <a:ext cx="6597737" cy="1791469"/>
+          </a:xfrm>
+          <a:prstGeom prst="rect">
+            <a:avLst/>
+          </a:prstGeom>
+        </p:spPr>
+      </p:pic>
     </p:spTree>
     <p:extLst>
       <p:ext uri="{BB962C8B-B14F-4D97-AF65-F5344CB8AC3E}">
@@ -3484,6 +3637,374 @@
 </file>
 
 <file path=ppt/slides/slide3.xml><?xml version="1.0" encoding="utf-8"?>
+<p:sld xmlns:a="http://schemas.openxmlformats.org/drawingml/2006/main" xmlns:r="http://schemas.openxmlformats.org/officeDocument/2006/relationships" xmlns:p="http://schemas.openxmlformats.org/presentationml/2006/main">
+  <p:cSld>
+    <p:spTree>
+      <p:nvGrpSpPr>
+        <p:cNvPr id="1" name="">
+          <a:extLst>
+            <a:ext uri="{FF2B5EF4-FFF2-40B4-BE49-F238E27FC236}">
+              <a16:creationId xmlns:a16="http://schemas.microsoft.com/office/drawing/2014/main" id="{5EEED560-5581-6939-B001-81DD30F5EEB8}"/>
+            </a:ext>
+          </a:extLst>
+        </p:cNvPr>
+        <p:cNvGrpSpPr/>
+        <p:nvPr/>
+      </p:nvGrpSpPr>
+      <p:grpSpPr>
+        <a:xfrm>
+          <a:off x="0" y="0"/>
+          <a:ext cx="0" cy="0"/>
+          <a:chOff x="0" y="0"/>
+          <a:chExt cx="0" cy="0"/>
+        </a:xfrm>
+      </p:grpSpPr>
+      <p:sp>
+        <p:nvSpPr>
+          <p:cNvPr id="3" name="TextBox 2">
+            <a:extLst>
+              <a:ext uri="{FF2B5EF4-FFF2-40B4-BE49-F238E27FC236}">
+                <a16:creationId xmlns:a16="http://schemas.microsoft.com/office/drawing/2014/main" id="{744BC804-A21E-C9F3-19F5-93AEB7C30CE9}"/>
+              </a:ext>
+            </a:extLst>
+          </p:cNvPr>
+          <p:cNvSpPr txBox="1"/>
+          <p:nvPr/>
+        </p:nvSpPr>
+        <p:spPr>
+          <a:xfrm>
+            <a:off x="217714" y="255046"/>
+            <a:ext cx="11756571" cy="355354"/>
+          </a:xfrm>
+          <a:prstGeom prst="rect">
+            <a:avLst/>
+          </a:prstGeom>
+          <a:noFill/>
+        </p:spPr>
+        <p:txBody>
+          <a:bodyPr wrap="square">
+            <a:spAutoFit/>
+          </a:bodyPr>
+          <a:lstStyle/>
+          <a:p>
+            <a:pPr>
+              <a:lnSpc>
+                <a:spcPct val="150000"/>
+              </a:lnSpc>
+              <a:buNone/>
+            </a:pPr>
+            <a:r>
+              <a:rPr lang="az-Latn-AZ" altLang="en-US" sz="1300">
+                <a:latin typeface="Arial" panose="020B0604020202020204" pitchFamily="34" charset="0"/>
+              </a:rPr>
+              <a:t>Digər əsas məsələ odur ki, laraveldə bu cür ara boşluqları xətaya səbəb ola bilər.</a:t>
+            </a:r>
+            <a:endParaRPr kumimoji="0" lang="en-US" altLang="en-US" sz="1300" b="0" i="0" u="none" strike="noStrike" cap="none" normalizeH="0" baseline="0">
+              <a:ln>
+                <a:noFill/>
+              </a:ln>
+              <a:solidFill>
+                <a:schemeClr val="tx1"/>
+              </a:solidFill>
+              <a:effectLst/>
+              <a:latin typeface="Arial" panose="020B0604020202020204" pitchFamily="34" charset="0"/>
+            </a:endParaRPr>
+          </a:p>
+        </p:txBody>
+      </p:sp>
+      <p:pic>
+        <p:nvPicPr>
+          <p:cNvPr id="4" name="Picture 3">
+            <a:extLst>
+              <a:ext uri="{FF2B5EF4-FFF2-40B4-BE49-F238E27FC236}">
+                <a16:creationId xmlns:a16="http://schemas.microsoft.com/office/drawing/2014/main" id="{1D74381F-65B7-9295-7209-DE9D1C582463}"/>
+              </a:ext>
+            </a:extLst>
+          </p:cNvPr>
+          <p:cNvPicPr>
+            <a:picLocks noChangeAspect="1"/>
+          </p:cNvPicPr>
+          <p:nvPr/>
+        </p:nvPicPr>
+        <p:blipFill>
+          <a:blip r:embed="rId2"/>
+          <a:stretch>
+            <a:fillRect/>
+          </a:stretch>
+        </p:blipFill>
+        <p:spPr>
+          <a:xfrm>
+            <a:off x="6580608" y="0"/>
+            <a:ext cx="5611391" cy="4313382"/>
+          </a:xfrm>
+          <a:prstGeom prst="rect">
+            <a:avLst/>
+          </a:prstGeom>
+        </p:spPr>
+      </p:pic>
+      <p:pic>
+        <p:nvPicPr>
+          <p:cNvPr id="6" name="Picture 5">
+            <a:extLst>
+              <a:ext uri="{FF2B5EF4-FFF2-40B4-BE49-F238E27FC236}">
+                <a16:creationId xmlns:a16="http://schemas.microsoft.com/office/drawing/2014/main" id="{38B08FCD-1D04-7A23-A101-ECE80D70B7F6}"/>
+              </a:ext>
+            </a:extLst>
+          </p:cNvPr>
+          <p:cNvPicPr>
+            <a:picLocks noChangeAspect="1"/>
+          </p:cNvPicPr>
+          <p:nvPr/>
+        </p:nvPicPr>
+        <p:blipFill>
+          <a:blip r:embed="rId3"/>
+          <a:stretch>
+            <a:fillRect/>
+          </a:stretch>
+        </p:blipFill>
+        <p:spPr>
+          <a:xfrm>
+            <a:off x="0" y="5000366"/>
+            <a:ext cx="7468642" cy="1857634"/>
+          </a:xfrm>
+          <a:prstGeom prst="rect">
+            <a:avLst/>
+          </a:prstGeom>
+        </p:spPr>
+      </p:pic>
+    </p:spTree>
+    <p:extLst>
+      <p:ext uri="{BB962C8B-B14F-4D97-AF65-F5344CB8AC3E}">
+        <p14:creationId xmlns:p14="http://schemas.microsoft.com/office/powerpoint/2010/main" val="1735710943"/>
+      </p:ext>
+    </p:extLst>
+  </p:cSld>
+  <p:clrMapOvr>
+    <a:masterClrMapping/>
+  </p:clrMapOvr>
+</p:sld>
+</file>
+
+<file path=ppt/slides/slide4.xml><?xml version="1.0" encoding="utf-8"?>
+<p:sld xmlns:a="http://schemas.openxmlformats.org/drawingml/2006/main" xmlns:r="http://schemas.openxmlformats.org/officeDocument/2006/relationships" xmlns:p="http://schemas.openxmlformats.org/presentationml/2006/main">
+  <p:cSld>
+    <p:spTree>
+      <p:nvGrpSpPr>
+        <p:cNvPr id="1" name="">
+          <a:extLst>
+            <a:ext uri="{FF2B5EF4-FFF2-40B4-BE49-F238E27FC236}">
+              <a16:creationId xmlns:a16="http://schemas.microsoft.com/office/drawing/2014/main" id="{B679A516-856B-4C32-E2EF-ED595472EA3A}"/>
+            </a:ext>
+          </a:extLst>
+        </p:cNvPr>
+        <p:cNvGrpSpPr/>
+        <p:nvPr/>
+      </p:nvGrpSpPr>
+      <p:grpSpPr>
+        <a:xfrm>
+          <a:off x="0" y="0"/>
+          <a:ext cx="0" cy="0"/>
+          <a:chOff x="0" y="0"/>
+          <a:chExt cx="0" cy="0"/>
+        </a:xfrm>
+      </p:grpSpPr>
+      <p:sp>
+        <p:nvSpPr>
+          <p:cNvPr id="3" name="TextBox 2">
+            <a:extLst>
+              <a:ext uri="{FF2B5EF4-FFF2-40B4-BE49-F238E27FC236}">
+                <a16:creationId xmlns:a16="http://schemas.microsoft.com/office/drawing/2014/main" id="{4601E06C-AE78-937D-6A03-4DC0B00BD8D0}"/>
+              </a:ext>
+            </a:extLst>
+          </p:cNvPr>
+          <p:cNvSpPr txBox="1"/>
+          <p:nvPr/>
+        </p:nvSpPr>
+        <p:spPr>
+          <a:xfrm>
+            <a:off x="217714" y="255046"/>
+            <a:ext cx="11756571" cy="355354"/>
+          </a:xfrm>
+          <a:prstGeom prst="rect">
+            <a:avLst/>
+          </a:prstGeom>
+          <a:noFill/>
+        </p:spPr>
+        <p:txBody>
+          <a:bodyPr wrap="square">
+            <a:spAutoFit/>
+          </a:bodyPr>
+          <a:lstStyle/>
+          <a:p>
+            <a:pPr>
+              <a:lnSpc>
+                <a:spcPct val="150000"/>
+              </a:lnSpc>
+              <a:buNone/>
+            </a:pPr>
+            <a:r>
+              <a:rPr lang="az-Latn-AZ" altLang="en-US" sz="1300">
+                <a:latin typeface="Arial" panose="020B0604020202020204" pitchFamily="34" charset="0"/>
+              </a:rPr>
+              <a:t>Əlavə edilən data.</a:t>
+            </a:r>
+            <a:endParaRPr kumimoji="0" lang="en-US" altLang="en-US" sz="1300" b="0" i="0" u="none" strike="noStrike" cap="none" normalizeH="0" baseline="0">
+              <a:ln>
+                <a:noFill/>
+              </a:ln>
+              <a:solidFill>
+                <a:schemeClr val="tx1"/>
+              </a:solidFill>
+              <a:effectLst/>
+              <a:latin typeface="Arial" panose="020B0604020202020204" pitchFamily="34" charset="0"/>
+            </a:endParaRPr>
+          </a:p>
+        </p:txBody>
+      </p:sp>
+      <p:pic>
+        <p:nvPicPr>
+          <p:cNvPr id="4" name="Picture 3">
+            <a:extLst>
+              <a:ext uri="{FF2B5EF4-FFF2-40B4-BE49-F238E27FC236}">
+                <a16:creationId xmlns:a16="http://schemas.microsoft.com/office/drawing/2014/main" id="{2340B87B-3CED-47BB-4450-43AE5E76B4D7}"/>
+              </a:ext>
+            </a:extLst>
+          </p:cNvPr>
+          <p:cNvPicPr>
+            <a:picLocks noChangeAspect="1"/>
+          </p:cNvPicPr>
+          <p:nvPr/>
+        </p:nvPicPr>
+        <p:blipFill>
+          <a:blip r:embed="rId2"/>
+          <a:stretch>
+            <a:fillRect/>
+          </a:stretch>
+        </p:blipFill>
+        <p:spPr>
+          <a:xfrm>
+            <a:off x="604071" y="2519235"/>
+            <a:ext cx="10983858" cy="1819529"/>
+          </a:xfrm>
+          <a:prstGeom prst="rect">
+            <a:avLst/>
+          </a:prstGeom>
+          <a:ln w="38100" cap="sq">
+            <a:solidFill>
+              <a:srgbClr val="000000"/>
+            </a:solidFill>
+            <a:prstDash val="solid"/>
+            <a:miter lim="800000"/>
+          </a:ln>
+          <a:effectLst>
+            <a:outerShdw blurRad="50800" dist="38100" dir="2700000" algn="tl" rotWithShape="0">
+              <a:srgbClr val="000000">
+                <a:alpha val="43000"/>
+              </a:srgbClr>
+            </a:outerShdw>
+          </a:effectLst>
+        </p:spPr>
+      </p:pic>
+    </p:spTree>
+    <p:extLst>
+      <p:ext uri="{BB962C8B-B14F-4D97-AF65-F5344CB8AC3E}">
+        <p14:creationId xmlns:p14="http://schemas.microsoft.com/office/powerpoint/2010/main" val="4058992698"/>
+      </p:ext>
+    </p:extLst>
+  </p:cSld>
+  <p:clrMapOvr>
+    <a:masterClrMapping/>
+  </p:clrMapOvr>
+</p:sld>
+</file>
+
+<file path=ppt/slides/slide5.xml><?xml version="1.0" encoding="utf-8"?>
+<p:sld xmlns:a="http://schemas.openxmlformats.org/drawingml/2006/main" xmlns:r="http://schemas.openxmlformats.org/officeDocument/2006/relationships" xmlns:p="http://schemas.openxmlformats.org/presentationml/2006/main">
+  <p:cSld>
+    <p:spTree>
+      <p:nvGrpSpPr>
+        <p:cNvPr id="1" name="">
+          <a:extLst>
+            <a:ext uri="{FF2B5EF4-FFF2-40B4-BE49-F238E27FC236}">
+              <a16:creationId xmlns:a16="http://schemas.microsoft.com/office/drawing/2014/main" id="{8B7474D7-3B50-CDBF-9FBA-1BB8E63AD863}"/>
+            </a:ext>
+          </a:extLst>
+        </p:cNvPr>
+        <p:cNvGrpSpPr/>
+        <p:nvPr/>
+      </p:nvGrpSpPr>
+      <p:grpSpPr>
+        <a:xfrm>
+          <a:off x="0" y="0"/>
+          <a:ext cx="0" cy="0"/>
+          <a:chOff x="0" y="0"/>
+          <a:chExt cx="0" cy="0"/>
+        </a:xfrm>
+      </p:grpSpPr>
+      <p:sp>
+        <p:nvSpPr>
+          <p:cNvPr id="3" name="TextBox 2">
+            <a:extLst>
+              <a:ext uri="{FF2B5EF4-FFF2-40B4-BE49-F238E27FC236}">
+                <a16:creationId xmlns:a16="http://schemas.microsoft.com/office/drawing/2014/main" id="{A216C944-9640-30A6-5F60-CD7E425D4FED}"/>
+              </a:ext>
+            </a:extLst>
+          </p:cNvPr>
+          <p:cNvSpPr txBox="1"/>
+          <p:nvPr/>
+        </p:nvSpPr>
+        <p:spPr>
+          <a:xfrm>
+            <a:off x="217714" y="255046"/>
+            <a:ext cx="11756571" cy="355354"/>
+          </a:xfrm>
+          <a:prstGeom prst="rect">
+            <a:avLst/>
+          </a:prstGeom>
+          <a:noFill/>
+        </p:spPr>
+        <p:txBody>
+          <a:bodyPr wrap="square">
+            <a:spAutoFit/>
+          </a:bodyPr>
+          <a:lstStyle/>
+          <a:p>
+            <a:pPr>
+              <a:lnSpc>
+                <a:spcPct val="150000"/>
+              </a:lnSpc>
+              <a:buNone/>
+            </a:pPr>
+            <a:r>
+              <a:rPr kumimoji="0" lang="en-US" altLang="en-US" sz="1300" b="0" i="0" u="none" strike="noStrike" cap="none" normalizeH="0" baseline="0">
+                <a:ln>
+                  <a:noFill/>
+                </a:ln>
+                <a:solidFill>
+                  <a:schemeClr val="tx1"/>
+                </a:solidFill>
+                <a:effectLst/>
+                <a:latin typeface="Arial" panose="020B0604020202020204" pitchFamily="34" charset="0"/>
+              </a:rPr>
+              <a:t>.</a:t>
+            </a:r>
+          </a:p>
+        </p:txBody>
+      </p:sp>
+    </p:spTree>
+    <p:extLst>
+      <p:ext uri="{BB962C8B-B14F-4D97-AF65-F5344CB8AC3E}">
+        <p14:creationId xmlns:p14="http://schemas.microsoft.com/office/powerpoint/2010/main" val="1029654531"/>
+      </p:ext>
+    </p:extLst>
+  </p:cSld>
+  <p:clrMapOvr>
+    <a:masterClrMapping/>
+  </p:clrMapOvr>
+</p:sld>
+</file>
+
+<file path=ppt/slides/slide6.xml><?xml version="1.0" encoding="utf-8"?>
 <p:sld xmlns:a="http://schemas.openxmlformats.org/drawingml/2006/main" xmlns:r="http://schemas.openxmlformats.org/officeDocument/2006/relationships" xmlns:p="http://schemas.openxmlformats.org/presentationml/2006/main">
   <p:cSld>
     <p:spTree>

</xml_diff>